<commit_message>
Update presentation with new content
</commit_message>
<xml_diff>
--- a/report/presentation.pptx
+++ b/report/presentation.pptx
@@ -3515,13 +3515,40 @@
           <a:lstStyle/>
           <a:p>
             <a:r>
-              <a:rPr sz="1200" b="0">
+              <a:rPr sz="1200" b="0" dirty="0" err="1">
                 <a:solidFill>
                   <a:srgbClr val="687484"/>
                 </a:solidFill>
                 <a:latin typeface="Leelawadee UI"/>
               </a:rPr>
-              <a:t>ภาคการศึกษา: Final Semester, Academic Year 2568</a:t>
+              <a:t>ภาคการศึกษา</a:t>
+            </a:r>
+            <a:r>
+              <a:rPr sz="1200" b="0" dirty="0">
+                <a:solidFill>
+                  <a:srgbClr val="687484"/>
+                </a:solidFill>
+                <a:latin typeface="Leelawadee UI"/>
+              </a:rPr>
+              <a:t>: </a:t>
+            </a:r>
+            <a:r>
+              <a:rPr lang="en-US" sz="1200" dirty="0">
+                <a:solidFill>
+                  <a:srgbClr val="687484"/>
+                </a:solidFill>
+                <a:latin typeface="Leelawadee UI"/>
+              </a:rPr>
+              <a:t>Second</a:t>
+            </a:r>
+            <a:r>
+              <a:rPr sz="1200" b="0" dirty="0">
+                <a:solidFill>
+                  <a:srgbClr val="687484"/>
+                </a:solidFill>
+                <a:latin typeface="Leelawadee UI"/>
+              </a:rPr>
+              <a:t> Semester, Academic Year 2568</a:t>
             </a:r>
           </a:p>
         </p:txBody>

</xml_diff>

<commit_message>
Update report document with team member IDs
</commit_message>
<xml_diff>
--- a/report/presentation.pptx
+++ b/report/presentation.pptx
@@ -3271,7 +3271,7 @@
         <p:spPr>
           <a:xfrm>
             <a:off x="768096" y="4508992"/>
-            <a:ext cx="3977640" cy="523220"/>
+            <a:ext cx="5257800" cy="523220"/>
           </a:xfrm>
           <a:prstGeom prst="rect">
             <a:avLst/>
@@ -3320,6 +3320,21 @@
               </a:rPr>
               <a:t>Ngamsukkasemsri</a:t>
             </a:r>
+            <a:r>
+              <a:rPr lang="th-TH" sz="1400" dirty="0">
+                <a:solidFill>
+                  <a:srgbClr val="323A46"/>
+                </a:solidFill>
+                <a:latin typeface="Leelawadee UI"/>
+              </a:rPr>
+              <a:t>	6633109021</a:t>
+            </a:r>
+            <a:endParaRPr lang="en-US" sz="1400" dirty="0">
+              <a:solidFill>
+                <a:srgbClr val="323A46"/>
+              </a:solidFill>
+              <a:latin typeface="Leelawadee UI"/>
+            </a:endParaRPr>
           </a:p>
           <a:p>
             <a:r>
@@ -3366,6 +3381,15 @@
                 <a:latin typeface="Leelawadee UI"/>
               </a:rPr>
               <a:t>Porapakpenjul</a:t>
+            </a:r>
+            <a:r>
+              <a:rPr lang="th-TH" sz="1400" dirty="0">
+                <a:solidFill>
+                  <a:srgbClr val="323A46"/>
+                </a:solidFill>
+                <a:latin typeface="Leelawadee UI"/>
+              </a:rPr>
+              <a:t>		6630368721</a:t>
             </a:r>
             <a:endParaRPr lang="en-US" sz="1400" dirty="0">
               <a:solidFill>
@@ -3700,7 +3724,13 @@
       </p:sp>
       <p:pic>
         <p:nvPicPr>
-          <p:cNvPr id="4" name="Picture 3" descr="plots.png"/>
+          <p:cNvPr id="8" name="Picture 7">
+            <a:extLst>
+              <a:ext uri="{FF2B5EF4-FFF2-40B4-BE49-F238E27FC236}">
+                <a16:creationId xmlns:a16="http://schemas.microsoft.com/office/drawing/2014/main" id="{83AFEA5E-370C-A89D-089B-8CA714274405}"/>
+              </a:ext>
+            </a:extLst>
+          </p:cNvPr>
           <p:cNvPicPr>
             <a:picLocks noChangeAspect="1"/>
           </p:cNvPicPr>
@@ -3714,72 +3744,14 @@
         </p:blipFill>
         <p:spPr>
           <a:xfrm>
-            <a:off x="640080" y="1600200"/>
-            <a:ext cx="5577840" cy="3346704"/>
+            <a:off x="2807592" y="1627632"/>
+            <a:ext cx="6723119" cy="4032210"/>
           </a:xfrm>
           <a:prstGeom prst="rect">
             <a:avLst/>
           </a:prstGeom>
         </p:spPr>
       </p:pic>
-      <p:pic>
-        <p:nvPicPr>
-          <p:cNvPr id="5" name="Picture 4" descr="demo_strip.png"/>
-          <p:cNvPicPr>
-            <a:picLocks noChangeAspect="1"/>
-          </p:cNvPicPr>
-          <p:nvPr/>
-        </p:nvPicPr>
-        <p:blipFill>
-          <a:blip r:embed="rId3"/>
-          <a:stretch>
-            <a:fillRect/>
-          </a:stretch>
-        </p:blipFill>
-        <p:spPr>
-          <a:xfrm>
-            <a:off x="6492240" y="1737360"/>
-            <a:ext cx="5029200" cy="554355"/>
-          </a:xfrm>
-          <a:prstGeom prst="rect">
-            <a:avLst/>
-          </a:prstGeom>
-        </p:spPr>
-      </p:pic>
-      <p:sp>
-        <p:nvSpPr>
-          <p:cNvPr id="6" name="TextBox 5"/>
-          <p:cNvSpPr txBox="1"/>
-          <p:nvPr/>
-        </p:nvSpPr>
-        <p:spPr>
-          <a:xfrm>
-            <a:off x="731520" y="5577840"/>
-            <a:ext cx="10789920" cy="411480"/>
-          </a:xfrm>
-          <a:prstGeom prst="rect">
-            <a:avLst/>
-          </a:prstGeom>
-          <a:noFill/>
-        </p:spPr>
-        <p:txBody>
-          <a:bodyPr wrap="square" anchor="t">
-            <a:spAutoFit/>
-          </a:bodyPr>
-          <a:lstStyle/>
-          <a:p>
-            <a:r>
-              <a:rPr sz="1500" b="0">
-                <a:solidFill>
-                  <a:srgbClr val="687484"/>
-                </a:solidFill>
-                <a:latin typeface="Leelawadee UI"/>
-              </a:rPr>
-              <a:t>ซ้าย: กราฟผล scaling benchmark จาก `experiments/results/plots.png` ขวา: เฟรมตัวอย่างจาก demo video ที่เปรียบเทียบ baseline กับ proposed แบบ side-by-side</a:t>
-            </a:r>
-          </a:p>
-        </p:txBody>
-      </p:sp>
     </p:spTree>
   </p:cSld>
   <p:clrMapOvr>
@@ -3900,7 +3872,7 @@
         <p:spPr>
           <a:xfrm>
             <a:off x="777240" y="1783080"/>
-            <a:ext cx="10332720" cy="4297680"/>
+            <a:ext cx="10332720" cy="2267287"/>
           </a:xfrm>
           <a:prstGeom prst="rect">
             <a:avLst/>
@@ -3925,7 +3897,36 @@
               </a:defRPr>
             </a:pPr>
             <a:r>
-              <a:t>จุดแข็ง: proposed ลด temporal jitter ได้โดยไม่เปลี่ยน interface และไม่ต้องพึ่ง learned weights</a:t>
+              <a:rPr dirty="0" err="1"/>
+              <a:t>จุดแข็ง</a:t>
+            </a:r>
+            <a:r>
+              <a:rPr dirty="0"/>
+              <a:t>: proposed </a:t>
+            </a:r>
+            <a:r>
+              <a:rPr dirty="0" err="1"/>
+              <a:t>ลด</a:t>
+            </a:r>
+            <a:r>
+              <a:rPr dirty="0"/>
+              <a:t> temporal jitter </a:t>
+            </a:r>
+            <a:r>
+              <a:rPr dirty="0" err="1"/>
+              <a:t>ได้โดยไม่เปลี่ยน</a:t>
+            </a:r>
+            <a:r>
+              <a:rPr dirty="0"/>
+              <a:t> interface </a:t>
+            </a:r>
+            <a:r>
+              <a:rPr dirty="0" err="1"/>
+              <a:t>และไม่ต้องพึ่ง</a:t>
+            </a:r>
+            <a:r>
+              <a:rPr dirty="0"/>
+              <a:t> learned weights</a:t>
             </a:r>
           </a:p>
           <a:p>
@@ -3941,8 +3942,34 @@
               </a:defRPr>
             </a:pPr>
             <a:r>
-              <a:t>จุดแข็ง: repository มี benchmark, tests, plots, demo video และ pipeline สำหรับข้อมูลจริงครบ</a:t>
-            </a:r>
+              <a:rPr dirty="0" err="1"/>
+              <a:t>จุดแข็ง</a:t>
+            </a:r>
+            <a:r>
+              <a:rPr dirty="0"/>
+              <a:t>: repository </a:t>
+            </a:r>
+            <a:r>
+              <a:rPr dirty="0" err="1"/>
+              <a:t>มี</a:t>
+            </a:r>
+            <a:r>
+              <a:rPr dirty="0"/>
+              <a:t> benchmark, tests, plots, demo video </a:t>
+            </a:r>
+            <a:r>
+              <a:rPr dirty="0" err="1"/>
+              <a:t>และ</a:t>
+            </a:r>
+            <a:r>
+              <a:rPr dirty="0"/>
+              <a:t> pipeline </a:t>
+            </a:r>
+            <a:r>
+              <a:rPr dirty="0" err="1"/>
+              <a:t>สำหรับข้อมูลจริงครบ</a:t>
+            </a:r>
+            <a:endParaRPr dirty="0"/>
           </a:p>
           <a:p>
             <a:pPr>
@@ -3957,8 +3984,26 @@
               </a:defRPr>
             </a:pPr>
             <a:r>
-              <a:t>ข้อจำกัด: benchmark เชิงปริมาณยังโฟกัสที่ motion primitive หลักเพียงชนิดเดียว</a:t>
-            </a:r>
+              <a:rPr dirty="0" err="1"/>
+              <a:t>ข้อจำกัด</a:t>
+            </a:r>
+            <a:r>
+              <a:rPr dirty="0"/>
+              <a:t>: benchmark </a:t>
+            </a:r>
+            <a:r>
+              <a:rPr dirty="0" err="1"/>
+              <a:t>เชิงปริมาณยังโฟกัสที่</a:t>
+            </a:r>
+            <a:r>
+              <a:rPr dirty="0"/>
+              <a:t> motion primitive </a:t>
+            </a:r>
+            <a:r>
+              <a:rPr dirty="0" err="1"/>
+              <a:t>หลักเพียงชนิดเดียว</a:t>
+            </a:r>
+            <a:endParaRPr dirty="0"/>
           </a:p>
           <a:p>
             <a:pPr>
@@ -3973,8 +4018,46 @@
               </a:defRPr>
             </a:pPr>
             <a:r>
-              <a:t>ข้อจำกัด: repo ไม่ได้ commit human recording จริงไว้โดยตรง เพราะข้อมูล landmark จากผู้ใช้มีประเด็นด้าน privacy</a:t>
-            </a:r>
+              <a:rPr dirty="0" err="1"/>
+              <a:t>ข้อจำกัด</a:t>
+            </a:r>
+            <a:r>
+              <a:rPr dirty="0"/>
+              <a:t>: repo </a:t>
+            </a:r>
+            <a:r>
+              <a:rPr dirty="0" err="1"/>
+              <a:t>ไม่ได้</a:t>
+            </a:r>
+            <a:r>
+              <a:rPr dirty="0"/>
+              <a:t> commit human recording </a:t>
+            </a:r>
+            <a:r>
+              <a:rPr dirty="0" err="1"/>
+              <a:t>จริงไว้โดยตรง</a:t>
+            </a:r>
+            <a:r>
+              <a:rPr dirty="0"/>
+              <a:t> </a:t>
+            </a:r>
+            <a:r>
+              <a:rPr dirty="0" err="1"/>
+              <a:t>เพราะข้อมูล</a:t>
+            </a:r>
+            <a:r>
+              <a:rPr dirty="0"/>
+              <a:t> landmark </a:t>
+            </a:r>
+            <a:r>
+              <a:rPr dirty="0" err="1"/>
+              <a:t>จากผู้ใช้มีประเด็นด้าน</a:t>
+            </a:r>
+            <a:r>
+              <a:rPr dirty="0"/>
+              <a:t> privacy</a:t>
+            </a:r>
+            <a:endParaRPr lang="en-US" dirty="0"/>
           </a:p>
           <a:p>
             <a:pPr>
@@ -3989,7 +4072,94 @@
               </a:defRPr>
             </a:pPr>
             <a:r>
-              <a:t>งานต่อยอด: เชื่อม skeleton เข้ากับ animated avatar, เพิ่ม motion curves และขยาย benchmark ไปทุก exercise mode</a:t>
+              <a:rPr lang="th-TH" dirty="0"/>
+              <a:t>ข้อจำกัด</a:t>
+            </a:r>
+            <a:r>
+              <a:rPr lang="en-US" dirty="0"/>
+              <a:t>: </a:t>
+            </a:r>
+            <a:r>
+              <a:rPr lang="th-TH" dirty="0"/>
+              <a:t>ถ้า </a:t>
+            </a:r>
+            <a:r>
+              <a:rPr lang="en-US" dirty="0"/>
+              <a:t>camera </a:t>
+            </a:r>
+            <a:r>
+              <a:rPr lang="th-TH" dirty="0"/>
+              <a:t>ใกล้จะเห็นแค่ครึ่งตัวทำให้มีการ </a:t>
+            </a:r>
+            <a:r>
+              <a:rPr lang="en-US" dirty="0"/>
+              <a:t>track </a:t>
+            </a:r>
+            <a:r>
+              <a:rPr lang="th-TH" dirty="0"/>
+              <a:t>ผิดพลาด ในอนาคตอาจจะแก้ให้ให้ดีขึ้นได้</a:t>
+            </a:r>
+            <a:endParaRPr dirty="0"/>
+          </a:p>
+          <a:p>
+            <a:pPr>
+              <a:spcAft>
+                <a:spcPts val="800"/>
+              </a:spcAft>
+              <a:defRPr sz="1800">
+                <a:solidFill>
+                  <a:srgbClr val="323A46"/>
+                </a:solidFill>
+                <a:latin typeface="Leelawadee UI"/>
+              </a:defRPr>
+            </a:pPr>
+            <a:r>
+              <a:rPr dirty="0" err="1"/>
+              <a:t>งานต่อยอด</a:t>
+            </a:r>
+            <a:r>
+              <a:rPr dirty="0"/>
+              <a:t>: </a:t>
+            </a:r>
+            <a:r>
+              <a:rPr dirty="0" err="1"/>
+              <a:t>เชื่อม</a:t>
+            </a:r>
+            <a:r>
+              <a:rPr dirty="0"/>
+              <a:t> skeleton </a:t>
+            </a:r>
+            <a:r>
+              <a:rPr dirty="0" err="1"/>
+              <a:t>เข้ากับ</a:t>
+            </a:r>
+            <a:r>
+              <a:rPr dirty="0"/>
+              <a:t> animated avatar, </a:t>
+            </a:r>
+            <a:r>
+              <a:rPr dirty="0" err="1"/>
+              <a:t>เพิ่ม</a:t>
+            </a:r>
+            <a:r>
+              <a:rPr dirty="0"/>
+              <a:t> motion curves </a:t>
+            </a:r>
+            <a:r>
+              <a:rPr dirty="0" err="1"/>
+              <a:t>และขยาย</a:t>
+            </a:r>
+            <a:r>
+              <a:rPr dirty="0"/>
+              <a:t> benchmark </a:t>
+            </a:r>
+            <a:r>
+              <a:rPr dirty="0" err="1"/>
+              <a:t>ไปทุก</a:t>
+            </a:r>
+            <a:r>
+              <a:rPr dirty="0"/>
+              <a:t> exercise mode</a:t>
             </a:r>
           </a:p>
         </p:txBody>
@@ -7208,7 +7378,32 @@
               </a:defRPr>
             </a:pPr>
             <a:r>
-              <a:t>Scaling benchmark ใช้ข้อมูลสังเคราะห์ 3 ขนาด: 1k, 10k และ 100k frames</a:t>
+              <a:rPr dirty="0"/>
+              <a:t>Scaling benchmark </a:t>
+            </a:r>
+            <a:r>
+              <a:rPr dirty="0" err="1"/>
+              <a:t>ใช้ข้อมูลสังเคราะห์</a:t>
+            </a:r>
+            <a:r>
+              <a:rPr dirty="0"/>
+              <a:t> 3 </a:t>
+            </a:r>
+            <a:r>
+              <a:rPr dirty="0" err="1"/>
+              <a:t>ขนาด</a:t>
+            </a:r>
+            <a:r>
+              <a:rPr dirty="0"/>
+              <a:t>: 1k, 10k </a:t>
+            </a:r>
+            <a:r>
+              <a:rPr dirty="0" err="1"/>
+              <a:t>และ</a:t>
+            </a:r>
+            <a:r>
+              <a:rPr dirty="0"/>
+              <a:t> 100k frames</a:t>
             </a:r>
           </a:p>
           <a:p>
@@ -7224,7 +7419,28 @@
               </a:defRPr>
             </a:pPr>
             <a:r>
-              <a:t>ตัวสร้างข้อมูลเพิ่มทั้ง angle noise และ visibility dropout เพื่อทดสอบ temporal robustness</a:t>
+              <a:rPr dirty="0" err="1"/>
+              <a:t>ตัวสร้างข้อมูลเพิ่มทั้ง</a:t>
+            </a:r>
+            <a:r>
+              <a:rPr dirty="0"/>
+              <a:t> angle noise </a:t>
+            </a:r>
+            <a:r>
+              <a:rPr dirty="0" err="1"/>
+              <a:t>และ</a:t>
+            </a:r>
+            <a:r>
+              <a:rPr dirty="0"/>
+              <a:t> visibility dropout </a:t>
+            </a:r>
+            <a:r>
+              <a:rPr dirty="0" err="1"/>
+              <a:t>เพื่อทดสอบ</a:t>
+            </a:r>
+            <a:r>
+              <a:rPr dirty="0"/>
+              <a:t> temporal robustness</a:t>
             </a:r>
           </a:p>
           <a:p>
@@ -7240,8 +7456,34 @@
               </a:defRPr>
             </a:pPr>
             <a:r>
-              <a:t>ข้อมูลจริงรองรับผ่านการอัด landmark CSV จาก webcam แล้ว replay เพื่อประเมินซ้ำ</a:t>
-            </a:r>
+              <a:rPr dirty="0" err="1"/>
+              <a:t>ข้อมูลจริงรองรับผ่านการอัด</a:t>
+            </a:r>
+            <a:r>
+              <a:rPr dirty="0"/>
+              <a:t> landmark CSV </a:t>
+            </a:r>
+            <a:r>
+              <a:rPr dirty="0" err="1"/>
+              <a:t>จาก</a:t>
+            </a:r>
+            <a:r>
+              <a:rPr dirty="0"/>
+              <a:t> webcam </a:t>
+            </a:r>
+            <a:r>
+              <a:rPr dirty="0" err="1"/>
+              <a:t>แล้ว</a:t>
+            </a:r>
+            <a:r>
+              <a:rPr dirty="0"/>
+              <a:t> replay </a:t>
+            </a:r>
+            <a:r>
+              <a:rPr dirty="0" err="1"/>
+              <a:t>เพื่อประเมินซ้ำ</a:t>
+            </a:r>
+            <a:endParaRPr dirty="0"/>
           </a:p>
           <a:p>
             <a:pPr>
@@ -7256,7 +7498,32 @@
               </a:defRPr>
             </a:pPr>
             <a:r>
-              <a:t>Metrics ที่ใช้: total runtime, ms/frame, peak traced memory, repetition count error และ side-switch jitter</a:t>
+              <a:rPr dirty="0"/>
+              <a:t>Metrics </a:t>
+            </a:r>
+            <a:r>
+              <a:rPr dirty="0" err="1"/>
+              <a:t>ที่ใช้</a:t>
+            </a:r>
+            <a:r>
+              <a:rPr dirty="0"/>
+              <a:t>: total runtime, </a:t>
+            </a:r>
+            <a:r>
+              <a:rPr dirty="0" err="1"/>
+              <a:t>ms</a:t>
+            </a:r>
+            <a:r>
+              <a:rPr dirty="0"/>
+              <a:t>/frame, peak traced memory, repetition count error </a:t>
+            </a:r>
+            <a:r>
+              <a:rPr dirty="0" err="1"/>
+              <a:t>และ</a:t>
+            </a:r>
+            <a:r>
+              <a:rPr dirty="0"/>
+              <a:t> side-switch jitter</a:t>
             </a:r>
           </a:p>
           <a:p>
@@ -7272,8 +7539,34 @@
               </a:defRPr>
             </a:pPr>
             <a:r>
-              <a:t>การตรวจสอบความถูกต้อง: `python -m unittest tests.test_simulation` ผ่าน</a:t>
-            </a:r>
+              <a:rPr dirty="0" err="1"/>
+              <a:t>การตรวจสอบความถูกต้อง</a:t>
+            </a:r>
+            <a:r>
+              <a:rPr dirty="0"/>
+              <a:t>: `python -m </a:t>
+            </a:r>
+            <a:r>
+              <a:rPr dirty="0" err="1"/>
+              <a:t>unittest</a:t>
+            </a:r>
+            <a:r>
+              <a:rPr dirty="0"/>
+              <a:t> </a:t>
+            </a:r>
+            <a:r>
+              <a:rPr dirty="0" err="1"/>
+              <a:t>tests.test_simulation</a:t>
+            </a:r>
+            <a:r>
+              <a:rPr dirty="0"/>
+              <a:t>` </a:t>
+            </a:r>
+            <a:r>
+              <a:rPr dirty="0" err="1"/>
+              <a:t>ผ่าน</a:t>
+            </a:r>
+            <a:endParaRPr dirty="0"/>
           </a:p>
         </p:txBody>
       </p:sp>
@@ -7285,7 +7578,7 @@
         </p:nvSpPr>
         <p:spPr>
           <a:xfrm>
-            <a:off x="6766560" y="1828800"/>
+            <a:off x="8138160" y="1828800"/>
             <a:ext cx="2377440" cy="1005840"/>
           </a:xfrm>
           <a:prstGeom prst="roundRect">
@@ -7320,7 +7613,7 @@
           <a:p>
             <a:pPr algn="ctr"/>
             <a:r>
-              <a:rPr sz="1100" b="1">
+              <a:rPr sz="1100" b="1" dirty="0">
                 <a:solidFill>
                   <a:srgbClr val="006D77"/>
                 </a:solidFill>
@@ -7332,79 +7625,13 @@
           <a:p>
             <a:pPr algn="ctr"/>
             <a:r>
-              <a:rPr sz="1700" b="1">
+              <a:rPr sz="1700" b="1" dirty="0">
                 <a:solidFill>
                   <a:srgbClr val="141820"/>
                 </a:solidFill>
                 <a:latin typeface="Leelawadee UI"/>
               </a:rPr>
               <a:t>1k / 10k / 100k</a:t>
-            </a:r>
-          </a:p>
-        </p:txBody>
-      </p:sp>
-      <p:sp>
-        <p:nvSpPr>
-          <p:cNvPr id="6" name="Rounded Rectangle 5"/>
-          <p:cNvSpPr/>
-          <p:nvPr/>
-        </p:nvSpPr>
-        <p:spPr>
-          <a:xfrm>
-            <a:off x="9326880" y="1828800"/>
-            <a:ext cx="2103120" cy="1005840"/>
-          </a:xfrm>
-          <a:prstGeom prst="roundRect">
-            <a:avLst/>
-          </a:prstGeom>
-          <a:solidFill>
-            <a:srgbClr val="E8F8F9"/>
-          </a:solidFill>
-          <a:ln w="19050">
-            <a:solidFill>
-              <a:srgbClr val="006D77"/>
-            </a:solidFill>
-          </a:ln>
-        </p:spPr>
-        <p:style>
-          <a:lnRef idx="1">
-            <a:schemeClr val="accent1"/>
-          </a:lnRef>
-          <a:fillRef idx="3">
-            <a:schemeClr val="accent1"/>
-          </a:fillRef>
-          <a:effectRef idx="2">
-            <a:schemeClr val="accent1"/>
-          </a:effectRef>
-          <a:fontRef idx="minor">
-            <a:schemeClr val="lt1"/>
-          </a:fontRef>
-        </p:style>
-        <p:txBody>
-          <a:bodyPr rtlCol="0" anchor="ctr"/>
-          <a:lstStyle/>
-          <a:p>
-            <a:pPr algn="ctr"/>
-            <a:r>
-              <a:rPr sz="1100" b="1">
-                <a:solidFill>
-                  <a:srgbClr val="006D77"/>
-                </a:solidFill>
-                <a:latin typeface="Leelawadee UI"/>
-              </a:rPr>
-              <a:t>Count Error</a:t>
-            </a:r>
-          </a:p>
-          <a:p>
-            <a:pPr algn="ctr"/>
-            <a:r>
-              <a:rPr sz="1700" b="1">
-                <a:solidFill>
-                  <a:srgbClr val="141820"/>
-                </a:solidFill>
-                <a:latin typeface="Leelawadee UI"/>
-              </a:rPr>
-              <a:t>0 ทุก scale</a:t>
             </a:r>
           </a:p>
         </p:txBody>

</xml_diff>

<commit_message>
Update report document with project ID and revised title
</commit_message>
<xml_diff>
--- a/report/presentation.pptx
+++ b/report/presentation.pptx
@@ -3204,7 +3204,7 @@
         <p:spPr>
           <a:xfrm>
             <a:off x="731520" y="1783080"/>
-            <a:ext cx="2560320" cy="274320"/>
+            <a:ext cx="5082684" cy="369332"/>
           </a:xfrm>
           <a:prstGeom prst="rect">
             <a:avLst/>
@@ -3233,8 +3233,32 @@
                 </a:solidFill>
                 <a:latin typeface="Leelawadee UI"/>
               </a:rPr>
-              <a:t> Computer Animation</a:t>
-            </a:r>
+              <a:t> </a:t>
+            </a:r>
+            <a:r>
+              <a:rPr sz="1800" b="1">
+                <a:solidFill>
+                  <a:srgbClr val="006D77"/>
+                </a:solidFill>
+                <a:latin typeface="Leelawadee UI"/>
+              </a:rPr>
+              <a:t>Computer Animation</a:t>
+            </a:r>
+            <a:r>
+              <a:rPr lang="en-US" sz="1800" b="1">
+                <a:solidFill>
+                  <a:srgbClr val="006D77"/>
+                </a:solidFill>
+                <a:latin typeface="Leelawadee UI"/>
+              </a:rPr>
+              <a:t> 2110512</a:t>
+            </a:r>
+            <a:endParaRPr sz="1800" b="1" dirty="0">
+              <a:solidFill>
+                <a:srgbClr val="006D77"/>
+              </a:solidFill>
+              <a:latin typeface="Leelawadee UI"/>
+            </a:endParaRPr>
           </a:p>
         </p:txBody>
       </p:sp>

</xml_diff>